<commit_message>
docs: trim the deck's replacement copy back to its boxes
Several rewrites had grown 1.4x to 3x past the text they replaced, which
overflows a fixed-size shape. Each is cut back to roughly the length of the
original, or of its sibling bullets on the same card.

Co-Authored-By: Claude Opus 5 <noreply@anthropic.com>
Claude-Session: https://claude.ai/code/session_018NL1vtTuhysz6xbiE9NQXe
</commit_message>
<xml_diff>
--- a/docs/aisleflow-mapf-presentation.pptx
+++ b/docs/aisleflow-mapf-presentation.pptx
@@ -7529,7 +7529,7 @@
                 <a:ea typeface="Calibri" pitchFamily="34" charset="-122"/>
                 <a:cs typeface="Calibri" pitchFamily="34" charset="-120"/>
               </a:rPr>
-              <a:t>Reward for moving the way the robot prefers. Its proximity decay turns out to be inert — β only breaks ties among candidates with equal progress, and the decay lowers it exactly where progress already decides.</a:t>
+              <a:t>Reward for moving the way the robot prefers. Its proximity decay is inert: β only breaks ties among equal-progress moves.</a:t>
             </a:r>
             <a:endParaRPr lang="en-US" sz="1150" dirty="0"/>
           </a:p>
@@ -7823,7 +7823,7 @@
                 <a:ea typeface="Calibri" pitchFamily="34" charset="-122"/>
                 <a:cs typeface="Calibri" pitchFamily="34" charset="-120"/>
               </a:rPr>
-              <a:t>A flat penalty per direction change. The cheapest term here, and the best single mechanism in the system: turning_cost_only is the top variant on warehouse_corridors.</a:t>
+              <a:t>A flat penalty per direction change. The cheapest term here, and the strongest single mechanism in the system.</a:t>
             </a:r>
             <a:endParaRPr lang="en-US" sz="1150" dirty="0"/>
           </a:p>
@@ -7970,7 +7970,7 @@
                 <a:ea typeface="Calibri" pitchFamily="34" charset="-122"/>
                 <a:cs typeface="Calibri" pitchFamily="34" charset="-120"/>
               </a:rPr>
-              <a:t>Local density, aisle occupancy and downstream lookahead, mixed into one term — now all three normalised to [0,1], so μ·C cannot outrank a step of progress.</a:t>
+              <a:t>Local density, aisle occupancy and downstream lookahead, all normalised to [0,1].</a:t>
             </a:r>
             <a:endParaRPr lang="en-US" sz="1150" dirty="0"/>
           </a:p>
@@ -8156,7 +8156,7 @@
                 <a:ea typeface="Calibri" pitchFamily="34" charset="-122"/>
                 <a:cs typeface="Calibri" pitchFamily="34" charset="-120"/>
               </a:rPr>
-              <a:t>The seventh term, ζ = 8.0, is where the aisle layer acts: the price of driving against a committed direction. Intended ordering α &gt; ζ &gt; β &gt; γ &gt; λ  (10 &gt; 8 &gt; 3 &gt; 2 &gt; 0.5). Two things had to change for that to hold at runtime — the aisle rules became penalties instead of rejections, and the congestion mixture was normalised, having been a robot count that reached μ·C = 9.6 against α·Δ = 10.</a:t>
+              <a:t>The seventh term, ζ = 8.0, is where the aisle layer acts: the price of driving against a committed direction. Ordering α &gt; ζ &gt; β &gt; γ &gt; λ. It holds only because the aisle rules became penalties rather than rejections, and the congestion mixture was normalised.</a:t>
             </a:r>
             <a:endParaRPr lang="en-US" sz="1000" dirty="0"/>
           </a:p>
@@ -8616,7 +8616,7 @@
                 <a:ea typeface="Calibri" pitchFamily="34" charset="-122"/>
                 <a:cs typeface="Calibri" pitchFamily="34" charset="-120"/>
               </a:rPr>
-              <a:t>opposing demand exceeds τ, or T_max expires</a:t>
+              <a:t>opposing demand, or T_max expires</a:t>
             </a:r>
             <a:endParaRPr lang="en-US" sz="1150" dirty="0"/>
           </a:p>
@@ -8933,7 +8933,7 @@
                 <a:ea typeface="Calibri" pitchFamily="34" charset="-122"/>
                 <a:cs typeface="Calibri" pitchFamily="34" charset="-120"/>
               </a:rPr>
-              <a:t>Minimum green: a direction is locked for T_min steps and only flips once the imbalance leaves a dead band of ±τ, so it cannot flap.</a:t>
+              <a:t>Minimum green: locked for T_min steps, and flips only outside a ±τ dead band, so it cannot flap.</a:t>
             </a:r>
             <a:endParaRPr lang="en-US" sz="1200" dirty="0"/>
           </a:p>
@@ -8957,7 +8957,7 @@
                 <a:ea typeface="Calibri" pitchFamily="34" charset="-122"/>
                 <a:cs typeface="Calibri" pitchFamily="34" charset="-120"/>
               </a:rPr>
-              <a:t>Maximum green: past T_max, any opposing demand at all forces a drain and a flip. Without it a balanced aisle — the normal case with pickups one side and deliveries the other — starves half its traffic forever.</a:t>
+              <a:t>Maximum green: past T_max, opposing demand forces a flip. Without it a balanced aisle starves.</a:t>
             </a:r>
             <a:endParaRPr lang="en-US" sz="1200" dirty="0"/>
           </a:p>
@@ -9076,7 +9076,7 @@
                 <a:ea typeface="Calibri" pitchFamily="34" charset="-122"/>
                 <a:cs typeface="Calibri" pitchFamily="34" charset="-120"/>
               </a:rPr>
-              <a:t>A robot at an entrance gets a ticket only if occupancy plus pending tickets stay under capacity. Capacity now applies to open aisles too; the ticket only to directional ones.</a:t>
+              <a:t>A robot at an entrance gets a ticket only if occupancy plus pending tickets stay under capacity.</a:t>
             </a:r>
             <a:endParaRPr lang="en-US" sz="1200" dirty="0"/>
           </a:p>
@@ -9124,7 +9124,7 @@
                 <a:ea typeface="Calibri" pitchFamily="34" charset="-122"/>
                 <a:cs typeface="Calibri" pitchFamily="34" charset="-120"/>
               </a:rPr>
-              <a:t>Direction restricts entry, not interior movement — and it is priced, not enforced, so a robot can always buy its way out.</a:t>
+              <a:t>Direction restricts entry, not interior movement — and it is priced, not enforced.</a:t>
             </a:r>
             <a:endParaRPr lang="en-US" sz="1200" dirty="0"/>
           </a:p>
@@ -10293,7 +10293,7 @@
                 <a:ea typeface="Calibri" pitchFamily="34" charset="-122"/>
                 <a:cs typeface="Calibri" pitchFamily="34" charset="-120"/>
               </a:rPr>
-              <a:t>No progress is only a precondition. A group escalates only when a cycle in the wait-for graph or a repeated joint configuration corroborates it — worth 0.134 against 0.022 tasks/step on warehouse_corridors.</a:t>
+              <a:t>No progress is only a precondition: a group escalates only when a wait-for cycle or a repeated configuration corroborates it. Worth 0.022 → 0.134 on corridors.</a:t>
             </a:r>
             <a:endParaRPr lang="en-US" sz="1150" dirty="0"/>
           </a:p>
@@ -10577,7 +10577,7 @@
                 <a:ea typeface="Calibri" pitchFamily="34" charset="-122"/>
                 <a:cs typeface="Calibri" pitchFamily="34" charset="-120"/>
               </a:rPr>
-              <a:t>Aisle direction and reservations were applied as hard rejections, deleting legal moves before scoring — while slide 2 says the high level never replaces PIBT's backtracking. Inheritance works because a robot can always be pushed aside. Pricing direction instead: 1.9× to 3.5× throughput, significant on all four maps.</a:t>
+              <a:t>Aisle direction and reservations were hard rejections, deleting legal moves before scoring — while slide 2 says the high level never replaces PIBT's backtracking. Inheritance needs to be able to push a robot aside. Pricing instead: 1.9× to 3.5×.</a:t>
             </a:r>
             <a:endParaRPr lang="en-US" sz="1200" dirty="0"/>
           </a:p>
@@ -10751,7 +10751,7 @@
                 <a:ea typeface="Calibri" pitchFamily="34" charset="-122"/>
                 <a:cs typeface="Calibri" pitchFamily="34" charset="-120"/>
               </a:rPr>
-              <a:t>reservations was a no-op unless direction_control was “aisle”, and the variant built to isolate it sets “robot” — so H3's treatment cell was a bit-identical copy of its control. On warehouse_bottleneck no aisle ever commits a direction at all, so H1's headline map produced no treatment either.</a:t>
+              <a:t>reservations was a no-op unless direction_control was “aisle”, and the variant built to isolate it sets “robot” — so H3's treatment cell was a copy of its control. On bottleneck no aisle ever commits a direction at all.</a:t>
             </a:r>
             <a:endParaRPr lang="en-US" sz="1200" dirty="0"/>
           </a:p>
@@ -10925,7 +10925,7 @@
                 <a:ea typeface="Calibri" pitchFamily="34" charset="-122"/>
                 <a:cs typeface="Calibri" pitchFamily="34" charset="-120"/>
               </a:rPr>
-              <a:t>A committed direction was held indefinitely unless the imbalance crossed τ — and a warehouse with pickups one side and deliveries the other produces balanced demand by construction. Corridors reached an absorbing deadlock: 35 of 35 robots stalled by t=120, identical state at t=199.</a:t>
+              <a:t>A committed direction was held indefinitely unless the imbalance crossed τ, and pickups one side with deliveries the other makes demand balanced. Corridors deadlocked: 35 of 35 stalled by t=120.</a:t>
             </a:r>
             <a:endParaRPr lang="en-US" sz="1200" dirty="0"/>
           </a:p>
@@ -11099,7 +11099,7 @@
                 <a:ea typeface="Calibri" pitchFamily="34" charset="-122"/>
                 <a:cs typeface="Calibri" pitchFamily="34" charset="-120"/>
               </a:rPr>
-              <a:t>Aisles were L and U shapes, so a one-way rule blocked corners both ways; recovery fired on healthy traffic; and the congestion term was a robot count mixed with two ratios, so it outranked the terms it modulates. 179 tests, up from 161.</a:t>
+              <a:t>Aisles were L and U shapes, so one-waying blocked corners both ways; recovery fired on healthy traffic; and the congestion term outranked the terms it modulates. 179 tests, up from 161.</a:t>
             </a:r>
             <a:endParaRPr lang="en-US" sz="1200" dirty="0"/>
           </a:p>
@@ -12020,7 +12020,7 @@
                 <a:ea typeface="Calibri" pitchFamily="34" charset="-122"/>
                 <a:cs typeface="Calibri" pitchFamily="34" charset="-120"/>
               </a:rPr>
-              <a:t>With both cells live: on warehouse_medium aisle direction alone raises throughput 0.337 to 0.405, entry admission alone drops it to 0.262, and both together land at 0.217. We had blamed the flag that helps and exonerated the one that costs.</a:t>
+              <a:t>With both cells live, on warehouse_medium: aisle direction alone raises throughput 0.337 → 0.405, entry admission alone drops it to 0.262, both land at 0.217.</a:t>
             </a:r>
             <a:endParaRPr lang="en-US" sz="1150" dirty="0"/>
           </a:p>
@@ -12128,7 +12128,7 @@
                 <a:ea typeface="Calibri" pitchFamily="34" charset="-122"/>
                 <a:cs typeface="Calibri" pitchFamily="34" charset="-120"/>
               </a:rPr>
-              <a:t>congestion_aware moved the movement score, the assignment cost and the blocking term together — the same confound the factorials exist to remove, one level down. Split, neither half helps alone.</a:t>
+              <a:t>congestion_aware moved the movement score, the assignment cost and the blocking term together — the same confound the factorials remove, one level down.</a:t>
             </a:r>
             <a:endParaRPr lang="en-US" sz="1150" dirty="0"/>
           </a:p>
@@ -13307,7 +13307,7 @@
                 <a:ea typeface="Calibri" pitchFamily="34" charset="-122"/>
                 <a:cs typeface="Calibri" pitchFamily="34" charset="-120"/>
               </a:rPr>
-              <a:t>Scored on the quantity each claim names — head-on conflicts for H3, per-aisle flow for H1 — not on global throughput. H1 is the interesting one: it fails on per-aisle flow and yet raises end-to-end throughput on three of four maps, because one-way aisles route each task through fewer aisle transits.</a:t>
+              <a:t>Scored on the quantity each claim names — head-on conflicts for H3, per-aisle flow for H1 — not on throughput. H1 fails its own metric yet raises end-to-end throughput on three of four maps.</a:t>
             </a:r>
             <a:endParaRPr lang="en-US" sz="1350" dirty="0"/>
           </a:p>
@@ -13939,7 +13939,7 @@
                 <a:ea typeface="Calibri" pitchFamily="34" charset="-122"/>
                 <a:cs typeface="Calibri" pitchFamily="34" charset="-120"/>
               </a:rPr>
-              <a:t>It was decisive while direction was a hard constraint: without it corridors reached an absorbing deadlock. Once counterflow is merely expensive, a robot can buy its way out of a starved aisle, so the two fixes are partly redundant. It stays because it makes the aisle layer correct, not merely survivable.</a:t>
+              <a:t>It was decisive while direction was a hard constraint: without it corridors reached an absorbing deadlock. Once counterflow is merely expensive a robot can buy its way out, so the two fixes are partly redundant. It stays because it makes the layer correct, not just survivable.</a:t>
             </a:r>
             <a:endParaRPr lang="en-US" sz="1250" dirty="0"/>
           </a:p>
@@ -14008,7 +14008,7 @@
                 <a:ea typeface="Calibri" pitchFamily="34" charset="-122"/>
                 <a:cs typeface="Calibri" pitchFamily="34" charset="-120"/>
               </a:rPr>
-              <a:t>Coordinated direction assignment across parallel aisles — the fix the last review called most promising — is implemented, and its measured effect is ±0.011. The collapse was a liveness failure, not a connectivity one.</a:t>
+              <a:t>Coordinated direction assignment across parallel aisles — the last review's most promising fix — is implemented, and measures ±0.011.</a:t>
             </a:r>
             <a:endParaRPr lang="en-US" sz="1250" dirty="0"/>
           </a:p>
@@ -14295,7 +14295,7 @@
                 <a:ea typeface="Calibri" pitchFamily="34" charset="-122"/>
                 <a:cs typeface="Calibri" pitchFamily="34" charset="-120"/>
               </a:rPr>
-              <a:t>It is the one repaired mechanism that still loses throughput on every map. The capacity model and the admission rule are both suspect; the mechanism is measurable now, so this is finally a tractable question.</a:t>
+              <a:t>The one repaired mechanism that still loses throughput on every map. Both the capacity model and the admission rule are suspect.</a:t>
             </a:r>
             <a:endParaRPr lang="en-US" sz="1200" dirty="0"/>
           </a:p>
@@ -14472,7 +14472,7 @@
                 <a:ea typeface="Calibri" pitchFamily="34" charset="-122"/>
                 <a:cs typeface="Calibri" pitchFamily="34" charset="-120"/>
               </a:rPr>
-              <a:t>It wins on warehouse_corridors and loses to plain lifelong PIBT on medium and narrow. Turning cost alone beats it on two maps, which suggests most of the benefit is anti-zigzag rather than directional.</a:t>
+              <a:t>It wins on corridors, loses on medium and narrow. Turning cost alone beats it on two maps.</a:t>
             </a:r>
             <a:endParaRPr lang="en-US" sz="1200" dirty="0"/>
           </a:p>
@@ -15629,7 +15629,7 @@
                 <a:ea typeface="Calibri" pitchFamily="34" charset="-122"/>
                 <a:cs typeface="Calibri" pitchFamily="34" charset="-120"/>
               </a:rPr>
-              <a:t>direction, congestion and turning cost decide which legal move PIBT tries first — they never replace its collision checks or its backtracking. Making that true in the code was worth 1.9× to 3.5× throughput.</a:t>
+              <a:t>direction, congestion and turning cost decide which legal move PIBT tries first — they never replace its collision checks or its backtracking. Worth 1.9× to 3.5× once true in the code.</a:t>
             </a:r>
             <a:endParaRPr lang="en-US" sz="1350" dirty="0"/>
           </a:p>
@@ -15879,7 +15879,7 @@
                 <a:ea typeface="Calibri" pitchFamily="34" charset="-122"/>
                 <a:cs typeface="Calibri" pitchFamily="34" charset="-120"/>
               </a:rPr>
-              <a:t>Forty years of MAPF converged on a mechanism — priority inheritance with backtracking — that a hundred lines of recursion capture. Both published baselines gridlock on maps where it does not, and plain lifelong PIBT still wins on the open grids.</a:t>
+              <a:t>Forty years of MAPF converged on a mechanism — priority inheritance with backtracking — that a hundred lines of recursion capture. Plain lifelong PIBT still wins on the open grids.</a:t>
             </a:r>
             <a:endParaRPr lang="en-US" sz="1350" dirty="0"/>
           </a:p>
@@ -16019,7 +16019,7 @@
                 <a:ea typeface="Calibri" pitchFamily="34" charset="-122"/>
                 <a:cs typeface="Calibri" pitchFamily="34" charset="-120"/>
               </a:rPr>
-              <a:t>Three of our six hypotheses were reported as failures. One had an empty treatment cell, one had a map where the treatment never fired, and one was rescuing deadlocks the architecture manufactured. Check that the treatment differs from the control before reading a verdict.</a:t>
+              <a:t>Three of our six hypotheses were reported as failures. One had an empty treatment cell, one a map where the treatment never fired, one was rescuing deadlocks we had manufactured.</a:t>
             </a:r>
             <a:endParaRPr lang="en-US" sz="1350" dirty="0"/>
           </a:p>
@@ -16159,7 +16159,7 @@
                 <a:ea typeface="Calibri" pitchFamily="34" charset="-122"/>
                 <a:cs typeface="Calibri" pitchFamily="34" charset="-120"/>
               </a:rPr>
-              <a:t>"Ranks candidates, never decides safety" appears three times in this deck. The code did the opposite, and that one line of architecture accounts for every collapse we had attributed to aisle management.</a:t>
+              <a:t>“Ranks candidates, never decides safety” appears three times in this deck. The code did the opposite, and that one line accounts for every collapse we blamed on aisle management.</a:t>
             </a:r>
             <a:endParaRPr lang="en-US" sz="1350" dirty="0"/>
           </a:p>

</xml_diff>

<commit_message>
docs: correct the soft-vs-hard multiplier range and its p-value claim
The measured range across the cells where an aisle actually commits a
direction is 1.9x to 3.1x, not 3.5x; warehouse_bottleneck's direction-only
cell is 1.00x because no aisle ever commits there, which is the "no
treatment" case rather than a null effect. The three cells slide 18 cites
are all p = 0.008, so "p <= 0.016 throughout" understated them while
implying it covered cells it did not.

Co-Authored-By: Claude Opus 5 <noreply@anthropic.com>
Claude-Session: https://claude.ai/code/session_018NL1vtTuhysz6xbiE9NQXe
</commit_message>
<xml_diff>
--- a/docs/aisleflow-mapf-presentation.pptx
+++ b/docs/aisleflow-mapf-presentation.pptx
@@ -10577,7 +10577,7 @@
                 <a:ea typeface="Calibri" pitchFamily="34" charset="-122"/>
                 <a:cs typeface="Calibri" pitchFamily="34" charset="-120"/>
               </a:rPr>
-              <a:t>Aisle direction and reservations were hard rejections, deleting legal moves before scoring — while slide 2 says the high level never replaces PIBT's backtracking. Inheritance needs to be able to push a robot aside. Pricing instead: 1.9× to 3.5×.</a:t>
+              <a:t>Aisle direction and reservations were hard rejections, deleting legal moves before scoring — while slide 2 says the high level never replaces PIBT's backtracking. Inheritance needs to be able to push a robot aside. Pricing instead: 1.9× to 3.1×.</a:t>
             </a:r>
             <a:endParaRPr lang="en-US" sz="1200" dirty="0"/>
           </a:p>
@@ -13591,7 +13591,7 @@
                 <a:ea typeface="Calibri" pitchFamily="34" charset="-122"/>
                 <a:cs typeface="Calibri" pitchFamily="34" charset="-120"/>
               </a:rPr>
-              <a:t>The largest effect in the repository: 0.084 → 0.158 on corridors, 0.112 → 0.304 on narrow, 0.161 → 0.405 on medium, p ≤ 0.016 throughout. A rejected move is a move priority inheritance can no longer use to unblock a chain.</a:t>
+              <a:t>The largest effect in the repository: 0.084 → 0.158 on corridors, 0.112 → 0.304 on narrow, 0.161 → 0.405 on medium, p = 0.008 on each. A rejected move is a move priority inheritance can no longer use to unblock a chain.</a:t>
             </a:r>
             <a:endParaRPr lang="en-US" sz="1250" dirty="0"/>
           </a:p>
@@ -15629,7 +15629,7 @@
                 <a:ea typeface="Calibri" pitchFamily="34" charset="-122"/>
                 <a:cs typeface="Calibri" pitchFamily="34" charset="-120"/>
               </a:rPr>
-              <a:t>direction, congestion and turning cost decide which legal move PIBT tries first — they never replace its collision checks or its backtracking. Worth 1.9× to 3.5× once true in the code.</a:t>
+              <a:t>direction, congestion and turning cost decide which legal move PIBT tries first — they never replace its collision checks or its backtracking. Worth 1.9× to 3.1× once true in the code.</a:t>
             </a:r>
             <a:endParaRPr lang="en-US" sz="1350" dirty="0"/>
           </a:p>

</xml_diff>

<commit_message>
docs: complete the baseline comparison with warehouse_medium
The medium map's five-planner sweep is 50 runs at 1-318 ms/step, so it was
collected in resumable batches (results/baseline_medium.json) rather than in
one pass.

lifelong_pibt 0.51, full_lda_pibt 0.26, RHCR 0.01, Token Passing 0.00. The
aisle layer is competitive on the two aisle-shaped maps and still clearly
behind on the open grid, which is the same shape the ablation tables show.
Slide 15 and chart 1, plus their embedded workbook, carry the new numbers, and
the runtime figures in the implementation notes are refreshed.

Co-Authored-By: Claude Opus 5 <noreply@anthropic.com>
Claude-Session: https://claude.ai/code/session_018NL1vtTuhysz6xbiE9NQXe
</commit_message>
<xml_diff>
--- a/docs/aisleflow-mapf-presentation.pptx
+++ b/docs/aisleflow-mapf-presentation.pptx
@@ -238,13 +238,13 @@
                 <c:formatCode>General</c:formatCode>
                 <c:ptCount val="3"/>
                 <c:pt idx="0">
-                  <c:v>0.11</c:v>
+                  <c:v>0.13</c:v>
                 </c:pt>
                 <c:pt idx="1">
-                  <c:v>0.16</c:v>
+                  <c:v>0.14</c:v>
                 </c:pt>
                 <c:pt idx="2">
-                  <c:v>0.5</c:v>
+                  <c:v>0.51</c:v>
                 </c:pt>
               </c:numCache>
             </c:numRef>
@@ -321,13 +321,13 @@
                 <c:formatCode>General</c:formatCode>
                 <c:ptCount val="3"/>
                 <c:pt idx="0">
-                  <c:v>0.15</c:v>
+                  <c:v>0.14</c:v>
                 </c:pt>
                 <c:pt idx="1">
-                  <c:v>0.02</c:v>
+                  <c:v>0.13</c:v>
                 </c:pt>
                 <c:pt idx="2">
-                  <c:v>0.2</c:v>
+                  <c:v>0.26</c:v>
                 </c:pt>
               </c:numCache>
             </c:numRef>
@@ -11416,7 +11416,7 @@
                 <a:ea typeface="Calibri" pitchFamily="34" charset="-122"/>
                 <a:cs typeface="Calibri" pitchFamily="34" charset="-120"/>
               </a:rPr>
-              <a:t>Plain lifelong_pibt — the simplest configuration already in the repo — beats both external baselines on every map, p &lt; 0.001 on throughput in every cell. Token Passing completes literally zero tasks on warehouse_corridors across all ten seeds.</a:t>
+              <a:t>Plain lifelong_pibt beats both external baselines on every map, p &lt; 0.001 on throughput in every cell. Token Passing completes literally zero tasks on warehouse_corridors across all ten seeds.</a:t>
             </a:r>
             <a:endParaRPr lang="en-US" sz="1200" dirty="0"/>
           </a:p>
@@ -11590,7 +11590,7 @@
                 <a:ea typeface="Calibri" pitchFamily="34" charset="-122"/>
                 <a:cs typeface="Calibri" pitchFamily="34" charset="-120"/>
               </a:rPr>
-              <a:t>And it is 30–190× cheaper</a:t>
+              <a:t>And it is 56–356× cheaper</a:t>
             </a:r>
             <a:endParaRPr lang="en-US" sz="1200" dirty="0"/>
           </a:p>
@@ -11632,7 +11632,7 @@
                 <a:ea typeface="Calibri" pitchFamily="34" charset="-122"/>
                 <a:cs typeface="Calibri" pitchFamily="34" charset="-120"/>
               </a:rPr>
-              <a:t>warehouse_medium, ms per step:  lifelong_pibt 0.83  ·  full_lda_pibt 2.40  ·  RHCR 58.1  ·  token_passing 158.7</a:t>
+              <a:t>warehouse_medium, ms per step:  lifelong_pibt 1.01  ·  full_lda_pibt 4.06  ·  RHCR 85.4  ·  token_passing 318.4</a:t>
             </a:r>
             <a:endParaRPr lang="en-US" sz="1150" dirty="0"/>
           </a:p>
@@ -11671,7 +11671,7 @@
                 <a:ea typeface="Calibri" pitchFamily="34" charset="-122"/>
                 <a:cs typeface="Calibri" pitchFamily="34" charset="-120"/>
               </a:rPr>
-              <a:t>10 seeds × 400 timesteps; permutation test vs. lifelong_pibt. Caveats: assignment is held constant so neither baseline runs the policy its own paper pairs it with, and RHCR's window/replan period are untuned defaults at a scale far below the one it targets.</a:t>
+              <a:t>10 seeds × 400 timesteps; permutation test vs. lifelong_pibt. full_lda_pibt now wins on bottleneck (0.14 vs 0.13, p = 0.016) and ties on corridors, where it used to lose 0.02 to 0.16. Assignment is held constant, so neither baseline runs its own paper's policy, and RHCR's window is an untuned default.</a:t>
             </a:r>
             <a:endParaRPr lang="en-US" sz="1000" dirty="0"/>
           </a:p>

</xml_diff>